<commit_message>
docs: fix repository link in README and update poster for submission
</commit_message>
<xml_diff>
--- a/FoodStorageCA1/docs/FoodStorage_Poster.pptx
+++ b/FoodStorageCA1/docs/FoodStorage_Poster.pptx
@@ -3554,7 +3554,7 @@
                 </a:solidFill>
                 <a:latin typeface="Calibri"/>
               </a:rPr>
-              <a:t>Submission: 6 October 2026</a:t>
+              <a:t>Submission: October 2026</a:t>
             </a:r>
           </a:p>
         </p:txBody>
@@ -10423,7 +10423,7 @@
                 </a:solidFill>
                 <a:latin typeface="Calibri"/>
               </a:rPr>
-              <a:t>Delete this text and paste the commit-history screenshot here (Insert → Pictures), resized to fit this dashed box.</a:t>
+              <a:t>Cole aqui o print do historico. Atencao: o GitHub divide em 2 paginas - a pagina 1 tem so os commits da Grazielle e a pagina 2 os do Maycon. Capture as duas, lado a lado.</a:t>
             </a:r>
           </a:p>
         </p:txBody>

</xml_diff>

<commit_message>
docs: add GitHub commit history screenshot to poster
Updated the CA1 project poster with a screenshot of the GitHub commit history.

- Added visual evidence of project development progress.
- Documented the team's GitHub contributions.
- Updated the poster for the final project submission.
</commit_message>
<xml_diff>
--- a/FoodStorageCA1/docs/FoodStorage_Poster.pptx
+++ b/FoodStorageCA1/docs/FoodStorage_Poster.pptx
@@ -427,7 +427,7 @@
           <a:p>
             <a:fld id="{5BCAD085-E8A6-8845-BD4E-CB4CCA059FC4}" type="datetimeFigureOut">
               <a:rPr lang="en-US" smtClean="0"/>
-              <a:t>10/4/2026</a:t>
+              <a:t>10/27/26</a:t>
             </a:fld>
             <a:endParaRPr lang="en-US"/>
           </a:p>
@@ -595,7 +595,7 @@
           <a:p>
             <a:fld id="{5BCAD085-E8A6-8845-BD4E-CB4CCA059FC4}" type="datetimeFigureOut">
               <a:rPr lang="en-US" smtClean="0"/>
-              <a:t>10/4/2026</a:t>
+              <a:t>10/27/26</a:t>
             </a:fld>
             <a:endParaRPr lang="en-US"/>
           </a:p>
@@ -773,7 +773,7 @@
           <a:p>
             <a:fld id="{5BCAD085-E8A6-8845-BD4E-CB4CCA059FC4}" type="datetimeFigureOut">
               <a:rPr lang="en-US" smtClean="0"/>
-              <a:t>10/4/2026</a:t>
+              <a:t>10/27/26</a:t>
             </a:fld>
             <a:endParaRPr lang="en-US"/>
           </a:p>
@@ -941,7 +941,7 @@
           <a:p>
             <a:fld id="{5BCAD085-E8A6-8845-BD4E-CB4CCA059FC4}" type="datetimeFigureOut">
               <a:rPr lang="en-US" smtClean="0"/>
-              <a:t>10/4/2026</a:t>
+              <a:t>10/27/26</a:t>
             </a:fld>
             <a:endParaRPr lang="en-US"/>
           </a:p>
@@ -1186,7 +1186,7 @@
           <a:p>
             <a:fld id="{5BCAD085-E8A6-8845-BD4E-CB4CCA059FC4}" type="datetimeFigureOut">
               <a:rPr lang="en-US" smtClean="0"/>
-              <a:t>10/4/2026</a:t>
+              <a:t>10/27/26</a:t>
             </a:fld>
             <a:endParaRPr lang="en-US"/>
           </a:p>
@@ -1471,7 +1471,7 @@
           <a:p>
             <a:fld id="{5BCAD085-E8A6-8845-BD4E-CB4CCA059FC4}" type="datetimeFigureOut">
               <a:rPr lang="en-US" smtClean="0"/>
-              <a:t>10/4/2026</a:t>
+              <a:t>10/27/26</a:t>
             </a:fld>
             <a:endParaRPr lang="en-US"/>
           </a:p>
@@ -1890,7 +1890,7 @@
           <a:p>
             <a:fld id="{5BCAD085-E8A6-8845-BD4E-CB4CCA059FC4}" type="datetimeFigureOut">
               <a:rPr lang="en-US" smtClean="0"/>
-              <a:t>10/4/2026</a:t>
+              <a:t>10/27/26</a:t>
             </a:fld>
             <a:endParaRPr lang="en-US"/>
           </a:p>
@@ -2007,7 +2007,7 @@
           <a:p>
             <a:fld id="{5BCAD085-E8A6-8845-BD4E-CB4CCA059FC4}" type="datetimeFigureOut">
               <a:rPr lang="en-US" smtClean="0"/>
-              <a:t>10/4/2026</a:t>
+              <a:t>10/27/26</a:t>
             </a:fld>
             <a:endParaRPr lang="en-US"/>
           </a:p>
@@ -2102,7 +2102,7 @@
           <a:p>
             <a:fld id="{5BCAD085-E8A6-8845-BD4E-CB4CCA059FC4}" type="datetimeFigureOut">
               <a:rPr lang="en-US" smtClean="0"/>
-              <a:t>10/4/2026</a:t>
+              <a:t>10/27/26</a:t>
             </a:fld>
             <a:endParaRPr lang="en-US"/>
           </a:p>
@@ -2377,7 +2377,7 @@
           <a:p>
             <a:fld id="{5BCAD085-E8A6-8845-BD4E-CB4CCA059FC4}" type="datetimeFigureOut">
               <a:rPr lang="en-US" smtClean="0"/>
-              <a:t>10/4/2026</a:t>
+              <a:t>10/27/26</a:t>
             </a:fld>
             <a:endParaRPr lang="en-US"/>
           </a:p>
@@ -2629,7 +2629,7 @@
           <a:p>
             <a:fld id="{5BCAD085-E8A6-8845-BD4E-CB4CCA059FC4}" type="datetimeFigureOut">
               <a:rPr lang="en-US" smtClean="0"/>
-              <a:t>10/4/2026</a:t>
+              <a:t>10/27/26</a:t>
             </a:fld>
             <a:endParaRPr lang="en-US"/>
           </a:p>
@@ -2840,7 +2840,7 @@
           <a:p>
             <a:fld id="{5BCAD085-E8A6-8845-BD4E-CB4CCA059FC4}" type="datetimeFigureOut">
               <a:rPr lang="en-US" smtClean="0"/>
-              <a:t>10/4/2026</a:t>
+              <a:t>10/27/26</a:t>
             </a:fld>
             <a:endParaRPr lang="en-US"/>
           </a:p>
@@ -3554,7 +3554,25 @@
                 </a:solidFill>
                 <a:latin typeface="Calibri"/>
               </a:rPr>
-              <a:t>Submission: 6 October 2026</a:t>
+              <a:t>Submission: </a:t>
+            </a:r>
+            <a:r>
+              <a:rPr lang="en-GB" sz="1670" dirty="0">
+                <a:solidFill>
+                  <a:srgbClr val="C9D5E8"/>
+                </a:solidFill>
+                <a:latin typeface="Calibri"/>
+              </a:rPr>
+              <a:t>27 </a:t>
+            </a:r>
+            <a:r>
+              <a:rPr sz="1670" b="0" i="0" dirty="0">
+                <a:solidFill>
+                  <a:srgbClr val="C9D5E8"/>
+                </a:solidFill>
+                <a:latin typeface="Calibri"/>
+              </a:rPr>
+              <a:t>October 2026</a:t>
             </a:r>
           </a:p>
         </p:txBody>
@@ -10081,60 +10099,6 @@
               </a:rPr>
               <a:t>Maycon —  CircularDeque, FoodStorage, the model package, both exceptions, and their 22 tests</a:t>
             </a:r>
-            <a:r>
-              <a:rPr lang="en-IE" sz="2000" b="0" i="0" dirty="0">
-                <a:solidFill>
-                  <a:srgbClr val="1A1A1A"/>
-                </a:solidFill>
-                <a:latin typeface="Calibri"/>
-              </a:rPr>
-              <a:t/>
-            </a:r>
-            <a:r>
-              <a:rPr sz="2000" b="0" i="0" dirty="0">
-                <a:solidFill>
-                  <a:srgbClr val="1A1A1A"/>
-                </a:solidFill>
-                <a:latin typeface="Calibri"/>
-              </a:rPr>
-              <a:t/>
-            </a:r>
-            <a:r>
-              <a:rPr sz="2000" b="0" i="0" dirty="0" err="1">
-                <a:solidFill>
-                  <a:srgbClr val="1A1A1A"/>
-                </a:solidFill>
-                <a:latin typeface="Calibri"/>
-              </a:rPr>
-              <a:t/>
-            </a:r>
-            <a:r>
-              <a:rPr sz="2000" b="0" i="0" dirty="0">
-                <a:solidFill>
-                  <a:srgbClr val="1A1A1A"/>
-                </a:solidFill>
-                <a:latin typeface="Calibri"/>
-              </a:rPr>
-              <a:t/>
-            </a:r>
-            <a:r>
-              <a:rPr sz="2000" b="0" i="0" dirty="0" err="1">
-                <a:solidFill>
-                  <a:srgbClr val="1A1A1A"/>
-                </a:solidFill>
-                <a:latin typeface="Calibri"/>
-              </a:rPr>
-              <a:t/>
-            </a:r>
-            <a:r>
-              <a:rPr sz="2000" b="0" i="0" dirty="0">
-                <a:solidFill>
-                  <a:srgbClr val="1A1A1A"/>
-                </a:solidFill>
-                <a:latin typeface="Calibri"/>
-              </a:rPr>
-              <a:t/>
-            </a:r>
           </a:p>
           <a:p>
             <a:pPr algn="l">
@@ -10308,7 +10272,16 @@
                 </a:solidFill>
                 <a:latin typeface="Consolas"/>
               </a:rPr>
-              <a:t>github.com/MikeAlme13/CA1---Algorithms-Architecture</a:t>
+              <a:t>github.com</a:t>
+            </a:r>
+            <a:r>
+              <a:rPr sz="2300" b="1" i="0" dirty="0">
+                <a:solidFill>
+                  <a:srgbClr val="FFFFFF"/>
+                </a:solidFill>
+                <a:latin typeface="Consolas"/>
+              </a:rPr>
+              <a:t>/MikeAlme13/CA1---Algorithms-Architecture</a:t>
             </a:r>
           </a:p>
         </p:txBody>
@@ -10369,8 +10342,8 @@
         </p:nvSpPr>
         <p:spPr>
           <a:xfrm>
-            <a:off x="20942808" y="18841398"/>
-            <a:ext cx="8208263" cy="1536191"/>
+            <a:off x="20595336" y="18775996"/>
+            <a:ext cx="8208263" cy="660950"/>
           </a:xfrm>
           <a:prstGeom prst="rect">
             <a:avLst/>
@@ -10395,7 +10368,7 @@
               </a:spcAft>
             </a:pPr>
             <a:r>
-              <a:rPr sz="1939" b="1" i="0">
+              <a:rPr sz="1939" b="1" i="0" dirty="0">
                 <a:solidFill>
                   <a:srgbClr val="5A606A"/>
                 </a:solidFill>
@@ -10403,6 +10376,12 @@
               </a:rPr>
               <a:t>GITHUB COMMITS</a:t>
             </a:r>
+            <a:endParaRPr lang="en-GB" sz="1939" b="1" i="0" dirty="0">
+              <a:solidFill>
+                <a:srgbClr val="5A606A"/>
+              </a:solidFill>
+              <a:latin typeface="Calibri"/>
+            </a:endParaRPr>
           </a:p>
           <a:p>
             <a:pPr algn="ctr">
@@ -10413,21 +10392,78 @@
                 <a:spcPts val="0"/>
               </a:spcBef>
               <a:spcAft>
-                <a:spcPts val="0"/>
+                <a:spcPts val="525"/>
               </a:spcAft>
             </a:pPr>
-            <a:r>
-              <a:rPr sz="1580" b="0" i="0">
-                <a:solidFill>
-                  <a:srgbClr val="5A606A"/>
-                </a:solidFill>
-                <a:latin typeface="Calibri"/>
-              </a:rPr>
-              <a:t>Delete this text and paste the commit-history screenshot here (Insert → Pictures), resized to fit this dashed box.</a:t>
-            </a:r>
-          </a:p>
-        </p:txBody>
-      </p:sp>
+            <a:endParaRPr sz="1939" b="1" i="0" dirty="0">
+              <a:solidFill>
+                <a:srgbClr val="5A606A"/>
+              </a:solidFill>
+              <a:latin typeface="Calibri"/>
+            </a:endParaRPr>
+          </a:p>
+        </p:txBody>
+      </p:sp>
+      <p:pic>
+        <p:nvPicPr>
+          <p:cNvPr id="99" name="Picture 98">
+            <a:extLst>
+              <a:ext uri="{FF2B5EF4-FFF2-40B4-BE49-F238E27FC236}">
+                <a16:creationId xmlns:a16="http://schemas.microsoft.com/office/drawing/2014/main" id="{C0AE2721-4477-9D5C-D093-429A55F8B14F}"/>
+              </a:ext>
+            </a:extLst>
+          </p:cNvPr>
+          <p:cNvPicPr>
+            <a:picLocks noChangeAspect="1"/>
+          </p:cNvPicPr>
+          <p:nvPr/>
+        </p:nvPicPr>
+        <p:blipFill>
+          <a:blip r:embed="rId2"/>
+          <a:stretch>
+            <a:fillRect/>
+          </a:stretch>
+        </p:blipFill>
+        <p:spPr>
+          <a:xfrm>
+            <a:off x="20595336" y="18790712"/>
+            <a:ext cx="3135298" cy="1476917"/>
+          </a:xfrm>
+          <a:prstGeom prst="rect">
+            <a:avLst/>
+          </a:prstGeom>
+        </p:spPr>
+      </p:pic>
+      <p:pic>
+        <p:nvPicPr>
+          <p:cNvPr id="100" name="Picture 99">
+            <a:extLst>
+              <a:ext uri="{FF2B5EF4-FFF2-40B4-BE49-F238E27FC236}">
+                <a16:creationId xmlns:a16="http://schemas.microsoft.com/office/drawing/2014/main" id="{FF313EA9-F2F2-1732-35F1-9E2C9593EF9A}"/>
+              </a:ext>
+            </a:extLst>
+          </p:cNvPr>
+          <p:cNvPicPr>
+            <a:picLocks noChangeAspect="1"/>
+          </p:cNvPicPr>
+          <p:nvPr/>
+        </p:nvPicPr>
+        <p:blipFill>
+          <a:blip r:embed="rId3"/>
+          <a:stretch>
+            <a:fillRect/>
+          </a:stretch>
+        </p:blipFill>
+        <p:spPr>
+          <a:xfrm>
+            <a:off x="25922177" y="18616514"/>
+            <a:ext cx="3416599" cy="1946462"/>
+          </a:xfrm>
+          <a:prstGeom prst="rect">
+            <a:avLst/>
+          </a:prstGeom>
+        </p:spPr>
+      </p:pic>
     </p:spTree>
   </p:cSld>
   <p:clrMapOvr>

</xml_diff>